<commit_message>
Arizona Center for Hand to Shoulder Surgery: rebuild proposal on the updated George Brazil deck
Uses the updated AJAC / George Brazil proposal as the reference (now the
repo's Onyx_AJAC_Proposal.pptx): CFO as reviewer in the deliverables
table, updated staffing wording, adjusted spacing on slides 4 and 13.
Wordmark moved up into the logo footprint on the cover.

Co-Authored-By: Claude Fable 5.1 <noreply@anthropic.com>
Claude-Session: https://claude.ai/code/session_01KQiKzmv3wJWX8AFkC8re3n
</commit_message>
<xml_diff>
--- a/Onyx_AJAC_Proposal.pptx
+++ b/Onyx_AJAC_Proposal.pptx
@@ -4622,7 +4622,7 @@
                           <a:ea typeface="Calibri" pitchFamily="34" charset="-122"/>
                           <a:cs typeface="Calibri" pitchFamily="34" charset="-120"/>
                         </a:rPr>
-                        <a:t>Principal</a:t>
+                        <a:t>CFO</a:t>
                       </a:r>
                       <a:endParaRPr lang="en-US" sz="1100" dirty="0">
                         <a:latin typeface="Calibri" charset="0"/>
@@ -5156,7 +5156,7 @@
                           <a:ea typeface="Calibri" pitchFamily="34" charset="-122"/>
                           <a:cs typeface="Calibri" pitchFamily="34" charset="-120"/>
                         </a:rPr>
-                        <a:t>Controller and Principal</a:t>
+                        <a:t>Controller and CFO</a:t>
                       </a:r>
                       <a:endParaRPr lang="en-US" sz="1100" dirty="0">
                         <a:latin typeface="Calibri" charset="0"/>
@@ -5423,7 +5423,7 @@
                           <a:ea typeface="Calibri" pitchFamily="34" charset="-122"/>
                           <a:cs typeface="Calibri" pitchFamily="34" charset="-120"/>
                         </a:rPr>
-                        <a:t>Principal</a:t>
+                        <a:t>CFO</a:t>
                       </a:r>
                       <a:endParaRPr lang="en-US" sz="1100" dirty="0">
                         <a:latin typeface="Calibri" charset="0"/>
@@ -5690,7 +5690,7 @@
                           <a:ea typeface="Calibri" pitchFamily="34" charset="-122"/>
                           <a:cs typeface="Calibri" pitchFamily="34" charset="-120"/>
                         </a:rPr>
-                        <a:t>Principal</a:t>
+                        <a:t>CFO</a:t>
                       </a:r>
                       <a:endParaRPr lang="en-US" sz="1100" dirty="0">
                         <a:latin typeface="Calibri" charset="0"/>
@@ -5957,7 +5957,7 @@
                           <a:ea typeface="Calibri" pitchFamily="34" charset="-122"/>
                           <a:cs typeface="Calibri" pitchFamily="34" charset="-120"/>
                         </a:rPr>
-                        <a:t>Principal</a:t>
+                        <a:t>CFO</a:t>
                       </a:r>
                       <a:endParaRPr lang="en-US" sz="1100" dirty="0">
                         <a:latin typeface="Calibri" charset="0"/>
@@ -8545,7 +8545,7 @@
         </p:nvSpPr>
         <p:spPr>
           <a:xfrm>
-            <a:off x="7086600" y="4160520"/>
+            <a:off x="7086600" y="3977640"/>
             <a:ext cx="365760" cy="365760"/>
           </a:xfrm>
           <a:prstGeom prst="rect">
@@ -8584,7 +8584,7 @@
         </p:nvSpPr>
         <p:spPr>
           <a:xfrm>
-            <a:off x="7543800" y="4160520"/>
+            <a:off x="7543800" y="3977640"/>
             <a:ext cx="3779215" cy="274320"/>
           </a:xfrm>
           <a:prstGeom prst="rect">
@@ -8620,7 +8620,7 @@
         </p:nvSpPr>
         <p:spPr>
           <a:xfrm>
-            <a:off x="7543800" y="4434840"/>
+            <a:off x="7543800" y="4251960"/>
             <a:ext cx="3779215" cy="640080"/>
           </a:xfrm>
           <a:prstGeom prst="rect">
@@ -8656,7 +8656,7 @@
         </p:nvSpPr>
         <p:spPr>
           <a:xfrm>
-            <a:off x="7086600" y="5120640"/>
+            <a:off x="7086600" y="4937760"/>
             <a:ext cx="365760" cy="365760"/>
           </a:xfrm>
           <a:prstGeom prst="rect">
@@ -8695,7 +8695,7 @@
         </p:nvSpPr>
         <p:spPr>
           <a:xfrm>
-            <a:off x="7543800" y="5120640"/>
+            <a:off x="7543800" y="4937760"/>
             <a:ext cx="3779215" cy="274320"/>
           </a:xfrm>
           <a:prstGeom prst="rect">
@@ -8731,7 +8731,7 @@
         </p:nvSpPr>
         <p:spPr>
           <a:xfrm>
-            <a:off x="7543800" y="5394960"/>
+            <a:off x="7543800" y="5212080"/>
             <a:ext cx="3779215" cy="640080"/>
           </a:xfrm>
           <a:prstGeom prst="rect">
@@ -11074,7 +11074,7 @@
         </p:nvSpPr>
         <p:spPr>
           <a:xfrm>
-            <a:off x="548640" y="5212080"/>
+            <a:off x="548640" y="5065776"/>
             <a:ext cx="384048" cy="384048"/>
           </a:xfrm>
           <a:prstGeom prst="ellipse">
@@ -11106,7 +11106,7 @@
         </p:nvSpPr>
         <p:spPr>
           <a:xfrm>
-            <a:off x="548640" y="5212080"/>
+            <a:off x="548640" y="5065776"/>
             <a:ext cx="384048" cy="384048"/>
           </a:xfrm>
           <a:prstGeom prst="rect">
@@ -11142,7 +11142,7 @@
         </p:nvSpPr>
         <p:spPr>
           <a:xfrm>
-            <a:off x="1097280" y="5166360"/>
+            <a:off x="1097280" y="5020056"/>
             <a:ext cx="4937760" cy="274320"/>
           </a:xfrm>
           <a:prstGeom prst="rect">
@@ -11181,7 +11181,7 @@
         </p:nvSpPr>
         <p:spPr>
           <a:xfrm>
-            <a:off x="1097280" y="5440680"/>
+            <a:off x="1097280" y="5294376"/>
             <a:ext cx="4937760" cy="640080"/>
           </a:xfrm>
           <a:prstGeom prst="rect">
@@ -11360,7 +11360,7 @@
         </p:nvSpPr>
         <p:spPr>
           <a:xfrm>
-            <a:off x="6858000" y="3200400"/>
+            <a:off x="6858000" y="3090672"/>
             <a:ext cx="4510735" cy="274320"/>
           </a:xfrm>
           <a:prstGeom prst="rect">
@@ -11396,7 +11396,7 @@
         </p:nvSpPr>
         <p:spPr>
           <a:xfrm>
-            <a:off x="6858000" y="3474720"/>
+            <a:off x="6858000" y="3364992"/>
             <a:ext cx="4510735" cy="658368"/>
           </a:xfrm>
           <a:prstGeom prst="rect">
@@ -11418,7 +11418,7 @@
                   <a:schemeClr val="tx1"/>
                 </a:solidFill>
               </a:rPr>
-              <a:t>Reconciliations, schedules and transaction support prepared on our systems by accountants with ten or more years of experience, and reviewed in Scottsdale.</a:t>
+              <a:t>Reconciliations, schedules and transaction support prepared on our systems by accountants with ten or more years of experience.</a:t>
             </a:r>
             <a:endParaRPr lang="en-US" sz="1150" dirty="0"/>
           </a:p>
@@ -11432,7 +11432,7 @@
         </p:nvSpPr>
         <p:spPr>
           <a:xfrm>
-            <a:off x="6858000" y="4160520"/>
+            <a:off x="6858000" y="3867912"/>
             <a:ext cx="4510735" cy="274320"/>
           </a:xfrm>
           <a:prstGeom prst="rect">
@@ -11468,7 +11468,7 @@
         </p:nvSpPr>
         <p:spPr>
           <a:xfrm>
-            <a:off x="6858000" y="4434840"/>
+            <a:off x="6858000" y="4142232"/>
             <a:ext cx="4510735" cy="658368"/>
           </a:xfrm>
           <a:prstGeom prst="rect">
@@ -11504,7 +11504,7 @@
         </p:nvSpPr>
         <p:spPr>
           <a:xfrm>
-            <a:off x="6858000" y="5120640"/>
+            <a:off x="6858000" y="4828032"/>
             <a:ext cx="4510735" cy="274320"/>
           </a:xfrm>
           <a:prstGeom prst="rect">
@@ -11540,7 +11540,7 @@
         </p:nvSpPr>
         <p:spPr>
           <a:xfrm>
-            <a:off x="6858000" y="5394960"/>
+            <a:off x="6858000" y="5102352"/>
             <a:ext cx="4510735" cy="658368"/>
           </a:xfrm>
           <a:prstGeom prst="rect">
@@ -16142,7 +16142,7 @@
                   <a:schemeClr val="tx1"/>
                 </a:solidFill>
               </a:rPr>
-              <a:t>Weekly progress and budget update during the first 90 days, then a monthly review with Marc</a:t>
+              <a:t>Weekly progress and budget update during the first 90 days, then a monthly review with the executive team</a:t>
             </a:r>
             <a:endParaRPr lang="en-US" sz="1150" dirty="0"/>
           </a:p>
@@ -16379,7 +16379,7 @@
                   <a:schemeClr val="tx1"/>
                 </a:solidFill>
               </a:rPr>
-              <a:t>Leadership of the inventory project, with ONYX supporting the accounting and the Sage Intacct integration</a:t>
+              <a:t>Leadership of the inventory project, with ONYX supporting the accounting and the QStock and Sage Intacct integration</a:t>
             </a:r>
             <a:endParaRPr lang="en-US" sz="1150" dirty="0"/>
           </a:p>
@@ -16638,7 +16638,7 @@
                   <a:schemeClr val="tx1"/>
                 </a:solidFill>
               </a:rPr>
-              <a:t>Weekly progress and budget update during the first 90 days. Monthly review of results with Marc. Quarterly review of scope, staffing mix and fees. Annual planning session before the budget year.</a:t>
+              <a:t>Weekly progress and budget update during the first 90 days. Monthly review of results with the executive team. Quarterly review of scope, staffing mix and fees. Annual planning session before the budget year.</a:t>
             </a:r>
             <a:endParaRPr lang="en-US" sz="1150" dirty="0"/>
           </a:p>

</xml_diff>